<commit_message>
Remove test-duration timings from the test-report documents
Drop the wall-clock run time (e.g. "10.83s") from the DOCX/PPTX/PDF reports
and the tests README — the pass count and date are the meaningful facts;
timing is machine-dependent noise.

Co-Authored-By: Claude Opus 4.8 <noreply@anthropic.com>
</commit_message>
<xml_diff>
--- a/Meridian_Copilot_Test_Report.pptx
+++ b/Meridian_Copilot_Test_Report.pptx
@@ -3336,7 +3336,7 @@
                 </a:solidFill>
                 <a:latin typeface="Calibri"/>
               </a:rPr>
-              <a:t>65/65 tests passed   ·   10.83s   ·   15 July 2026</a:t>
+              <a:t>65/65 tests passed   ·   15 July 2026</a:t>
             </a:r>
           </a:p>
         </p:txBody>
@@ -3591,7 +3591,7 @@
                 </a:solidFill>
                 <a:latin typeface="Calibri"/>
               </a:rPr>
-              <a:t>65/65 passed in 10.83s  ·  offline, deterministic, repeatable</a:t>
+              <a:t>65/65 passed  ·  offline, deterministic, repeatable</a:t>
             </a:r>
           </a:p>
         </p:txBody>

</xml_diff>